<commit_message>
docs: update exam presentation slides and script
</commit_message>
<xml_diff>
--- a/presentazione_esame/Presentazione Barbagallo Emanuele.pptx
+++ b/presentazione_esame/Presentazione Barbagallo Emanuele.pptx
@@ -391,13 +391,13 @@
   <p:clrMapOvr>
     <a:masterClrMapping/>
   </p:clrMapOvr>
-  <mc:AlternateContent xmlns:mc="http://schemas.openxmlformats.org/markup-compatibility/2006">
-    <mc:Choice xmlns:p14="http://schemas.microsoft.com/office/powerpoint/2010/main" Requires="p14">
+  <mc:AlternateContent xmlns:mc="http://schemas.openxmlformats.org/markup-compatibility/2006" xmlns:p14="http://schemas.microsoft.com/office/powerpoint/2010/main">
+    <mc:Choice Requires="p14">
       <p:transition spd="med" p14:dur="700">
         <p:fade/>
       </p:transition>
     </mc:Choice>
-    <mc:Fallback>
+    <mc:Fallback xmlns="">
       <p:transition spd="med">
         <p:fade/>
       </p:transition>
@@ -571,13 +571,13 @@
   <p:clrMapOvr>
     <a:masterClrMapping/>
   </p:clrMapOvr>
-  <mc:AlternateContent xmlns:mc="http://schemas.openxmlformats.org/markup-compatibility/2006">
-    <mc:Choice xmlns:p14="http://schemas.microsoft.com/office/powerpoint/2010/main" Requires="p14">
+  <mc:AlternateContent xmlns:mc="http://schemas.openxmlformats.org/markup-compatibility/2006" xmlns:p14="http://schemas.microsoft.com/office/powerpoint/2010/main">
+    <mc:Choice Requires="p14">
       <p:transition spd="med" p14:dur="700">
         <p:fade/>
       </p:transition>
     </mc:Choice>
-    <mc:Fallback>
+    <mc:Fallback xmlns="">
       <p:transition spd="med">
         <p:fade/>
       </p:transition>
@@ -761,13 +761,13 @@
   <p:clrMapOvr>
     <a:masterClrMapping/>
   </p:clrMapOvr>
-  <mc:AlternateContent xmlns:mc="http://schemas.openxmlformats.org/markup-compatibility/2006">
-    <mc:Choice xmlns:p14="http://schemas.microsoft.com/office/powerpoint/2010/main" Requires="p14">
+  <mc:AlternateContent xmlns:mc="http://schemas.openxmlformats.org/markup-compatibility/2006" xmlns:p14="http://schemas.microsoft.com/office/powerpoint/2010/main">
+    <mc:Choice Requires="p14">
       <p:transition spd="med" p14:dur="700">
         <p:fade/>
       </p:transition>
     </mc:Choice>
-    <mc:Fallback>
+    <mc:Fallback xmlns="">
       <p:transition spd="med">
         <p:fade/>
       </p:transition>
@@ -941,13 +941,13 @@
   <p:clrMapOvr>
     <a:masterClrMapping/>
   </p:clrMapOvr>
-  <mc:AlternateContent xmlns:mc="http://schemas.openxmlformats.org/markup-compatibility/2006">
-    <mc:Choice xmlns:p14="http://schemas.microsoft.com/office/powerpoint/2010/main" Requires="p14">
+  <mc:AlternateContent xmlns:mc="http://schemas.openxmlformats.org/markup-compatibility/2006" xmlns:p14="http://schemas.microsoft.com/office/powerpoint/2010/main">
+    <mc:Choice Requires="p14">
       <p:transition spd="med" p14:dur="700">
         <p:fade/>
       </p:transition>
     </mc:Choice>
-    <mc:Fallback>
+    <mc:Fallback xmlns="">
       <p:transition spd="med">
         <p:fade/>
       </p:transition>
@@ -1198,13 +1198,13 @@
   <p:clrMapOvr>
     <a:masterClrMapping/>
   </p:clrMapOvr>
-  <mc:AlternateContent xmlns:mc="http://schemas.openxmlformats.org/markup-compatibility/2006">
-    <mc:Choice xmlns:p14="http://schemas.microsoft.com/office/powerpoint/2010/main" Requires="p14">
+  <mc:AlternateContent xmlns:mc="http://schemas.openxmlformats.org/markup-compatibility/2006" xmlns:p14="http://schemas.microsoft.com/office/powerpoint/2010/main">
+    <mc:Choice Requires="p14">
       <p:transition spd="med" p14:dur="700">
         <p:fade/>
       </p:transition>
     </mc:Choice>
-    <mc:Fallback>
+    <mc:Fallback xmlns="">
       <p:transition spd="med">
         <p:fade/>
       </p:transition>
@@ -1495,13 +1495,13 @@
   <p:clrMapOvr>
     <a:masterClrMapping/>
   </p:clrMapOvr>
-  <mc:AlternateContent xmlns:mc="http://schemas.openxmlformats.org/markup-compatibility/2006">
-    <mc:Choice xmlns:p14="http://schemas.microsoft.com/office/powerpoint/2010/main" Requires="p14">
+  <mc:AlternateContent xmlns:mc="http://schemas.openxmlformats.org/markup-compatibility/2006" xmlns:p14="http://schemas.microsoft.com/office/powerpoint/2010/main">
+    <mc:Choice Requires="p14">
       <p:transition spd="med" p14:dur="700">
         <p:fade/>
       </p:transition>
     </mc:Choice>
-    <mc:Fallback>
+    <mc:Fallback xmlns="">
       <p:transition spd="med">
         <p:fade/>
       </p:transition>
@@ -1926,13 +1926,13 @@
   <p:clrMapOvr>
     <a:masterClrMapping/>
   </p:clrMapOvr>
-  <mc:AlternateContent xmlns:mc="http://schemas.openxmlformats.org/markup-compatibility/2006">
-    <mc:Choice xmlns:p14="http://schemas.microsoft.com/office/powerpoint/2010/main" Requires="p14">
+  <mc:AlternateContent xmlns:mc="http://schemas.openxmlformats.org/markup-compatibility/2006" xmlns:p14="http://schemas.microsoft.com/office/powerpoint/2010/main">
+    <mc:Choice Requires="p14">
       <p:transition spd="med" p14:dur="700">
         <p:fade/>
       </p:transition>
     </mc:Choice>
-    <mc:Fallback>
+    <mc:Fallback xmlns="">
       <p:transition spd="med">
         <p:fade/>
       </p:transition>
@@ -2055,13 +2055,13 @@
   <p:clrMapOvr>
     <a:masterClrMapping/>
   </p:clrMapOvr>
-  <mc:AlternateContent xmlns:mc="http://schemas.openxmlformats.org/markup-compatibility/2006">
-    <mc:Choice xmlns:p14="http://schemas.microsoft.com/office/powerpoint/2010/main" Requires="p14">
+  <mc:AlternateContent xmlns:mc="http://schemas.openxmlformats.org/markup-compatibility/2006" xmlns:p14="http://schemas.microsoft.com/office/powerpoint/2010/main">
+    <mc:Choice Requires="p14">
       <p:transition spd="med" p14:dur="700">
         <p:fade/>
       </p:transition>
     </mc:Choice>
-    <mc:Fallback>
+    <mc:Fallback xmlns="">
       <p:transition spd="med">
         <p:fade/>
       </p:transition>
@@ -2162,13 +2162,13 @@
   <p:clrMapOvr>
     <a:masterClrMapping/>
   </p:clrMapOvr>
-  <mc:AlternateContent xmlns:mc="http://schemas.openxmlformats.org/markup-compatibility/2006">
-    <mc:Choice xmlns:p14="http://schemas.microsoft.com/office/powerpoint/2010/main" Requires="p14">
+  <mc:AlternateContent xmlns:mc="http://schemas.openxmlformats.org/markup-compatibility/2006" xmlns:p14="http://schemas.microsoft.com/office/powerpoint/2010/main">
+    <mc:Choice Requires="p14">
       <p:transition spd="med" p14:dur="700">
         <p:fade/>
       </p:transition>
     </mc:Choice>
-    <mc:Fallback>
+    <mc:Fallback xmlns="">
       <p:transition spd="med">
         <p:fade/>
       </p:transition>
@@ -2449,13 +2449,13 @@
   <p:clrMapOvr>
     <a:masterClrMapping/>
   </p:clrMapOvr>
-  <mc:AlternateContent xmlns:mc="http://schemas.openxmlformats.org/markup-compatibility/2006">
-    <mc:Choice xmlns:p14="http://schemas.microsoft.com/office/powerpoint/2010/main" Requires="p14">
+  <mc:AlternateContent xmlns:mc="http://schemas.openxmlformats.org/markup-compatibility/2006" xmlns:p14="http://schemas.microsoft.com/office/powerpoint/2010/main">
+    <mc:Choice Requires="p14">
       <p:transition spd="med" p14:dur="700">
         <p:fade/>
       </p:transition>
     </mc:Choice>
-    <mc:Fallback>
+    <mc:Fallback xmlns="">
       <p:transition spd="med">
         <p:fade/>
       </p:transition>
@@ -2713,13 +2713,13 @@
   <p:clrMapOvr>
     <a:masterClrMapping/>
   </p:clrMapOvr>
-  <mc:AlternateContent xmlns:mc="http://schemas.openxmlformats.org/markup-compatibility/2006">
-    <mc:Choice xmlns:p14="http://schemas.microsoft.com/office/powerpoint/2010/main" Requires="p14">
+  <mc:AlternateContent xmlns:mc="http://schemas.openxmlformats.org/markup-compatibility/2006" xmlns:p14="http://schemas.microsoft.com/office/powerpoint/2010/main">
+    <mc:Choice Requires="p14">
       <p:transition spd="med" p14:dur="700">
         <p:fade/>
       </p:transition>
     </mc:Choice>
-    <mc:Fallback>
+    <mc:Fallback xmlns="">
       <p:transition spd="med">
         <p:fade/>
       </p:transition>
@@ -2983,13 +2983,13 @@
     <p:sldLayoutId id="2147483658" r:id="rId10"/>
     <p:sldLayoutId id="2147483659" r:id="rId11"/>
   </p:sldLayoutIdLst>
-  <mc:AlternateContent xmlns:mc="http://schemas.openxmlformats.org/markup-compatibility/2006">
-    <mc:Choice xmlns:p14="http://schemas.microsoft.com/office/powerpoint/2010/main" Requires="p14">
+  <mc:AlternateContent xmlns:mc="http://schemas.openxmlformats.org/markup-compatibility/2006" xmlns:p14="http://schemas.microsoft.com/office/powerpoint/2010/main">
+    <mc:Choice Requires="p14">
       <p:transition spd="med" p14:dur="700">
         <p:fade/>
       </p:transition>
     </mc:Choice>
-    <mc:Fallback>
+    <mc:Fallback xmlns="">
       <p:transition spd="med">
         <p:fade/>
       </p:transition>
@@ -3485,13 +3485,13 @@
   <p:clrMapOvr>
     <a:masterClrMapping/>
   </p:clrMapOvr>
-  <mc:AlternateContent xmlns:mc="http://schemas.openxmlformats.org/markup-compatibility/2006">
-    <mc:Choice xmlns:p14="http://schemas.microsoft.com/office/powerpoint/2010/main" Requires="p14">
+  <mc:AlternateContent xmlns:mc="http://schemas.openxmlformats.org/markup-compatibility/2006" xmlns:p14="http://schemas.microsoft.com/office/powerpoint/2010/main">
+    <mc:Choice Requires="p14">
       <p:transition spd="med" p14:dur="700">
         <p:fade/>
       </p:transition>
     </mc:Choice>
-    <mc:Fallback>
+    <mc:Fallback xmlns="">
       <p:transition spd="med">
         <p:fade/>
       </p:transition>
@@ -4138,13 +4138,13 @@
   <p:clrMapOvr>
     <a:masterClrMapping/>
   </p:clrMapOvr>
-  <mc:AlternateContent xmlns:mc="http://schemas.openxmlformats.org/markup-compatibility/2006">
-    <mc:Choice xmlns:p14="http://schemas.microsoft.com/office/powerpoint/2010/main" Requires="p14">
+  <mc:AlternateContent xmlns:mc="http://schemas.openxmlformats.org/markup-compatibility/2006" xmlns:p14="http://schemas.microsoft.com/office/powerpoint/2010/main">
+    <mc:Choice Requires="p14">
       <p:transition spd="med" p14:dur="700">
         <p:fade/>
       </p:transition>
     </mc:Choice>
-    <mc:Fallback>
+    <mc:Fallback xmlns="">
       <p:transition spd="med">
         <p:fade/>
       </p:transition>
@@ -4638,13 +4638,13 @@
   <p:clrMapOvr>
     <a:masterClrMapping/>
   </p:clrMapOvr>
-  <mc:AlternateContent xmlns:mc="http://schemas.openxmlformats.org/markup-compatibility/2006">
-    <mc:Choice xmlns:p14="http://schemas.microsoft.com/office/powerpoint/2010/main" Requires="p14">
+  <mc:AlternateContent xmlns:mc="http://schemas.openxmlformats.org/markup-compatibility/2006" xmlns:p14="http://schemas.microsoft.com/office/powerpoint/2010/main">
+    <mc:Choice Requires="p14">
       <p:transition spd="med" p14:dur="700">
         <p:fade/>
       </p:transition>
     </mc:Choice>
-    <mc:Fallback>
+    <mc:Fallback xmlns="">
       <p:transition spd="med">
         <p:fade/>
       </p:transition>
@@ -5165,13 +5165,13 @@
   <p:clrMapOvr>
     <a:masterClrMapping/>
   </p:clrMapOvr>
-  <mc:AlternateContent xmlns:mc="http://schemas.openxmlformats.org/markup-compatibility/2006">
-    <mc:Choice xmlns:p14="http://schemas.microsoft.com/office/powerpoint/2010/main" Requires="p14">
+  <mc:AlternateContent xmlns:mc="http://schemas.openxmlformats.org/markup-compatibility/2006" xmlns:p14="http://schemas.microsoft.com/office/powerpoint/2010/main">
+    <mc:Choice Requires="p14">
       <p:transition spd="med" p14:dur="700">
         <p:fade/>
       </p:transition>
     </mc:Choice>
-    <mc:Fallback>
+    <mc:Fallback xmlns="">
       <p:transition spd="med">
         <p:fade/>
       </p:transition>
@@ -5925,7 +5925,7 @@
         <p:spPr>
           <a:xfrm>
             <a:off x="1367879" y="5060156"/>
-            <a:ext cx="4366170" cy="533400"/>
+            <a:ext cx="4366170" cy="553998"/>
           </a:xfrm>
           <a:prstGeom prst="rect">
             <a:avLst/>
@@ -5940,14 +5940,20 @@
           <a:p>
             <a:pPr algn="l"/>
             <a:r>
-              <a:rPr sz="1800" b="0" i="0" u="none">
+              <a:rPr lang="it-IT" sz="1800" b="0" i="0" u="none" dirty="0">
                 <a:solidFill>
                   <a:srgbClr val="475569"/>
                 </a:solidFill>
                 <a:latin typeface="Roboto"/>
               </a:rPr>
-              <a:t>Estrazione del Coefficiente di Diffusione (D).</a:t>
-            </a:r>
+              <a:t>Validazione algoritmica dei solutori in ambiente matematico controllato.</a:t>
+            </a:r>
+            <a:endParaRPr sz="1800" b="0" i="0" u="none" dirty="0">
+              <a:solidFill>
+                <a:srgbClr val="475569"/>
+              </a:solidFill>
+              <a:latin typeface="Roboto"/>
+            </a:endParaRPr>
           </a:p>
         </p:txBody>
       </p:sp>
@@ -6026,13 +6032,13 @@
   <p:clrMapOvr>
     <a:masterClrMapping/>
   </p:clrMapOvr>
-  <mc:AlternateContent xmlns:mc="http://schemas.openxmlformats.org/markup-compatibility/2006">
-    <mc:Choice xmlns:p14="http://schemas.microsoft.com/office/powerpoint/2010/main" Requires="p14">
+  <mc:AlternateContent xmlns:mc="http://schemas.openxmlformats.org/markup-compatibility/2006" xmlns:p14="http://schemas.microsoft.com/office/powerpoint/2010/main">
+    <mc:Choice Requires="p14">
       <p:transition spd="med" p14:dur="700">
         <p:fade/>
       </p:transition>
     </mc:Choice>
-    <mc:Fallback>
+    <mc:Fallback xmlns="">
       <p:transition spd="med">
         <p:fade/>
       </p:transition>
@@ -6736,13 +6742,13 @@
   <p:clrMapOvr>
     <a:masterClrMapping/>
   </p:clrMapOvr>
-  <mc:AlternateContent xmlns:mc="http://schemas.openxmlformats.org/markup-compatibility/2006">
-    <mc:Choice xmlns:p14="http://schemas.microsoft.com/office/powerpoint/2010/main" Requires="p14">
+  <mc:AlternateContent xmlns:mc="http://schemas.openxmlformats.org/markup-compatibility/2006" xmlns:p14="http://schemas.microsoft.com/office/powerpoint/2010/main">
+    <mc:Choice Requires="p14">
       <p:transition spd="med" p14:dur="700">
         <p:fade/>
       </p:transition>
     </mc:Choice>
-    <mc:Fallback>
+    <mc:Fallback xmlns="">
       <p:transition spd="med">
         <p:fade/>
       </p:transition>
@@ -7045,13 +7051,13 @@
   <p:clrMapOvr>
     <a:masterClrMapping/>
   </p:clrMapOvr>
-  <mc:AlternateContent xmlns:mc="http://schemas.openxmlformats.org/markup-compatibility/2006">
-    <mc:Choice xmlns:p14="http://schemas.microsoft.com/office/powerpoint/2010/main" Requires="p14">
+  <mc:AlternateContent xmlns:mc="http://schemas.openxmlformats.org/markup-compatibility/2006" xmlns:p14="http://schemas.microsoft.com/office/powerpoint/2010/main">
+    <mc:Choice Requires="p14">
       <p:transition spd="med" p14:dur="700">
         <p:fade/>
       </p:transition>
     </mc:Choice>
-    <mc:Fallback>
+    <mc:Fallback xmlns="">
       <p:transition spd="med">
         <p:fade/>
       </p:transition>
@@ -7587,13 +7593,13 @@
   <p:clrMapOvr>
     <a:masterClrMapping/>
   </p:clrMapOvr>
-  <mc:AlternateContent xmlns:mc="http://schemas.openxmlformats.org/markup-compatibility/2006">
-    <mc:Choice xmlns:p14="http://schemas.microsoft.com/office/powerpoint/2010/main" Requires="p14">
+  <mc:AlternateContent xmlns:mc="http://schemas.openxmlformats.org/markup-compatibility/2006" xmlns:p14="http://schemas.microsoft.com/office/powerpoint/2010/main">
+    <mc:Choice Requires="p14">
       <p:transition spd="med" p14:dur="700">
         <p:fade/>
       </p:transition>
     </mc:Choice>
-    <mc:Fallback>
+    <mc:Fallback xmlns="">
       <p:transition spd="med">
         <p:fade/>
       </p:transition>
@@ -8093,13 +8099,13 @@
   <p:clrMapOvr>
     <a:masterClrMapping/>
   </p:clrMapOvr>
-  <mc:AlternateContent xmlns:mc="http://schemas.openxmlformats.org/markup-compatibility/2006">
-    <mc:Choice xmlns:p14="http://schemas.microsoft.com/office/powerpoint/2010/main" Requires="p14">
+  <mc:AlternateContent xmlns:mc="http://schemas.openxmlformats.org/markup-compatibility/2006" xmlns:p14="http://schemas.microsoft.com/office/powerpoint/2010/main">
+    <mc:Choice Requires="p14">
       <p:transition spd="med" p14:dur="700">
         <p:fade/>
       </p:transition>
     </mc:Choice>
-    <mc:Fallback>
+    <mc:Fallback xmlns="">
       <p:transition spd="med">
         <p:fade/>
       </p:transition>
@@ -8691,8 +8697,8 @@
           </a:p>
         </p:txBody>
       </p:sp>
-      <mc:AlternateContent xmlns:mc="http://schemas.openxmlformats.org/markup-compatibility/2006">
-        <mc:Choice xmlns:a14="http://schemas.microsoft.com/office/drawing/2010/main" Requires="a14">
+      <mc:AlternateContent xmlns:mc="http://schemas.openxmlformats.org/markup-compatibility/2006" xmlns:a14="http://schemas.microsoft.com/office/drawing/2010/main">
+        <mc:Choice Requires="a14">
           <p:sp>
             <p:nvSpPr>
               <p:cNvPr id="16" name="TextBox 15"/>
@@ -8760,6 +8766,7 @@
                 </a:endParaRPr>
               </a:p>
               <a:p>
+                <a:pPr/>
                 <a14:m>
                   <m:oMathPara xmlns:m="http://schemas.openxmlformats.org/officeDocument/2006/math">
                     <m:oMath>
@@ -8929,7 +8936,7 @@
             </p:txBody>
           </p:sp>
         </mc:Choice>
-        <mc:Fallback>
+        <mc:Fallback xmlns="">
           <p:sp>
             <p:nvSpPr>
               <p:cNvPr id="16" name="TextBox 15"/>
@@ -9124,13 +9131,13 @@
   <p:clrMapOvr>
     <a:masterClrMapping/>
   </p:clrMapOvr>
-  <mc:AlternateContent xmlns:mc="http://schemas.openxmlformats.org/markup-compatibility/2006">
-    <mc:Choice xmlns:p14="http://schemas.microsoft.com/office/powerpoint/2010/main" Requires="p14">
+  <mc:AlternateContent xmlns:mc="http://schemas.openxmlformats.org/markup-compatibility/2006" xmlns:p14="http://schemas.microsoft.com/office/powerpoint/2010/main">
+    <mc:Choice Requires="p14">
       <p:transition spd="med" p14:dur="700">
         <p:fade/>
       </p:transition>
     </mc:Choice>
-    <mc:Fallback>
+    <mc:Fallback xmlns="">
       <p:transition spd="med">
         <p:fade/>
       </p:transition>
@@ -9846,13 +9853,13 @@
   <p:clrMapOvr>
     <a:masterClrMapping/>
   </p:clrMapOvr>
-  <mc:AlternateContent xmlns:mc="http://schemas.openxmlformats.org/markup-compatibility/2006">
-    <mc:Choice xmlns:p14="http://schemas.microsoft.com/office/powerpoint/2010/main" Requires="p14">
+  <mc:AlternateContent xmlns:mc="http://schemas.openxmlformats.org/markup-compatibility/2006" xmlns:p14="http://schemas.microsoft.com/office/powerpoint/2010/main">
+    <mc:Choice Requires="p14">
       <p:transition spd="med" p14:dur="700">
         <p:fade/>
       </p:transition>
     </mc:Choice>
-    <mc:Fallback>
+    <mc:Fallback xmlns="">
       <p:transition spd="med">
         <p:fade/>
       </p:transition>
@@ -10367,13 +10374,13 @@
   <p:clrMapOvr>
     <a:masterClrMapping/>
   </p:clrMapOvr>
-  <mc:AlternateContent xmlns:mc="http://schemas.openxmlformats.org/markup-compatibility/2006">
-    <mc:Choice xmlns:p14="http://schemas.microsoft.com/office/powerpoint/2010/main" Requires="p14">
+  <mc:AlternateContent xmlns:mc="http://schemas.openxmlformats.org/markup-compatibility/2006" xmlns:p14="http://schemas.microsoft.com/office/powerpoint/2010/main">
+    <mc:Choice Requires="p14">
       <p:transition spd="med" p14:dur="700">
         <p:fade/>
       </p:transition>
     </mc:Choice>
-    <mc:Fallback>
+    <mc:Fallback xmlns="">
       <p:transition spd="med">
         <p:fade/>
       </p:transition>

</xml_diff>